<commit_message>
Deck: correct the command examples after the launcher cleanup
Slide 9 still showed `./moa-engine ...`, which no longer exists. Uses
`python3 moa_engine.py` and names the two files in SEND THIS/. "dossier"
becomes "outreach list" on the pipeline and discussion slides to match the
rename.

Co-Authored-By: Claude Opus 5 (1M context) <noreply@anthropic.com>
</commit_message>
<xml_diff>
--- a/How the MOA sourcing engine works.pptx
+++ b/How the MOA sourcing engine works.pptx
@@ -5882,7 +5882,7 @@
                 </a:solidFill>
                 <a:latin typeface="Arial"/>
               </a:rPr>
-              <a:t>Should the dossier be shared with the whole AE group before the meeting?</a:t>
+              <a:t>Should the outreach list be shared with the whole AE group?</a:t>
             </a:r>
           </a:p>
         </p:txBody>
@@ -9031,7 +9031,7 @@
                 </a:solidFill>
                 <a:latin typeface="Arial"/>
               </a:rPr>
-              <a:t>· dossier + drafts</a:t>
+              <a:t>· outreach list + drafts</a:t>
             </a:r>
           </a:p>
         </p:txBody>
@@ -14902,7 +14902,7 @@
                 </a:solidFill>
                 <a:latin typeface="Arial"/>
               </a:rPr>
-              <a:t>EVERYDAY USE</a:t>
+              <a:t>EVERYDAY USE — most people just press the buttons; this is the same thing</a:t>
             </a:r>
           </a:p>
         </p:txBody>
@@ -14983,13 +14983,13 @@
               </a:spcAft>
             </a:pPr>
             <a:r>
-              <a:rPr sz="1100" b="0" i="0">
+              <a:rPr sz="1050" b="0" i="0">
                 <a:solidFill>
                   <a:srgbClr val="E8ECF1"/>
                 </a:solidFill>
                 <a:latin typeface="Menlo"/>
               </a:rPr>
-              <a:t>$ ./moa-engine check              # verify everything; writes nothing</a:t>
+              <a:t>$ python3 moa_engine.py check           # verify everything; writes nothing</a:t>
             </a:r>
           </a:p>
           <a:p>
@@ -15005,13 +15005,13 @@
               </a:spcAft>
             </a:pPr>
             <a:r>
-              <a:rPr sz="1100" b="0" i="0">
+              <a:rPr sz="1050" b="0" i="0">
                 <a:solidFill>
                   <a:srgbClr val="E8ECF1"/>
                 </a:solidFill>
                 <a:latin typeface="Menlo"/>
               </a:rPr>
-              <a:t>$ ./moa-engine scan --days 120    # preview candidates; writes nothing</a:t>
+              <a:t>$ python3 moa_engine.py scan --days 120 # preview candidates; writes nothing</a:t>
             </a:r>
           </a:p>
           <a:p>
@@ -15027,13 +15027,13 @@
               </a:spcAft>
             </a:pPr>
             <a:r>
-              <a:rPr sz="1100" b="0" i="0">
+              <a:rPr sz="1050" b="0" i="0">
                 <a:solidFill>
                   <a:srgbClr val="E8ECF1"/>
                 </a:solidFill>
                 <a:latin typeface="Menlo"/>
               </a:rPr>
-              <a:t>$ ./moa-engine update --go        # add new candidates to the queue</a:t>
+              <a:t>$ python3 moa_engine.py update --go     # add new candidates to the queue</a:t>
             </a:r>
           </a:p>
           <a:p>
@@ -15049,13 +15049,13 @@
               </a:spcAft>
             </a:pPr>
             <a:r>
-              <a:rPr sz="1100" b="0" i="0">
+              <a:rPr sz="1050" b="0" i="0">
                 <a:solidFill>
                   <a:srgbClr val="E8ECF1"/>
                 </a:solidFill>
                 <a:latin typeface="Menlo"/>
               </a:rPr>
-              <a:t>$ ./moa-engine dossier --go       # build the ASCPT dossier</a:t>
+              <a:t>$ python3 moa_engine.py dossier --go    # build the outreach list</a:t>
             </a:r>
           </a:p>
           <a:p>
@@ -15071,13 +15071,13 @@
               </a:spcAft>
             </a:pPr>
             <a:r>
-              <a:rPr sz="1100" b="0" i="0">
+              <a:rPr sz="1050" b="0" i="0">
                 <a:solidFill>
                   <a:srgbClr val="E8ECF1"/>
                 </a:solidFill>
                 <a:latin typeface="Menlo"/>
               </a:rPr>
-              <a:t>$ ./moa-engine invites --go       # draft the letters, once you've read it</a:t>
+              <a:t>$ python3 moa_engine.py invites --go    # draft the letters, once read</a:t>
             </a:r>
           </a:p>
         </p:txBody>
@@ -15200,13 +15200,13 @@
               </a:spcAft>
             </a:pPr>
             <a:r>
-              <a:rPr sz="1100" b="0" i="0">
+              <a:rPr sz="1050" b="0" i="0">
                 <a:solidFill>
                   <a:srgbClr val="E8ECF1"/>
                 </a:solidFill>
                 <a:latin typeface="Menlo"/>
               </a:rPr>
-              <a:t>$ ./moa-engine start              # monthly, 7th at 09:17</a:t>
+              <a:t>$ python3 moa_engine.py start           # monthly, 7th at 09:17</a:t>
             </a:r>
           </a:p>
           <a:p>
@@ -15222,13 +15222,13 @@
               </a:spcAft>
             </a:pPr>
             <a:r>
-              <a:rPr sz="1100" b="0" i="0">
+              <a:rPr sz="1050" b="0" i="0">
                 <a:solidFill>
                   <a:srgbClr val="E8ECF1"/>
                 </a:solidFill>
                 <a:latin typeface="Menlo"/>
               </a:rPr>
-              <a:t>$ ./moa-engine status             # on or off?</a:t>
+              <a:t>$ python3 moa_engine.py status          # on or off?</a:t>
             </a:r>
           </a:p>
           <a:p>
@@ -15244,13 +15244,13 @@
               </a:spcAft>
             </a:pPr>
             <a:r>
-              <a:rPr sz="1100" b="0" i="0">
+              <a:rPr sz="1050" b="0" i="0">
                 <a:solidFill>
                   <a:srgbClr val="E8ECF1"/>
                 </a:solidFill>
                 <a:latin typeface="Menlo"/>
               </a:rPr>
-              <a:t>$ ./moa-engine stop               # removes it completely</a:t>
+              <a:t>$ python3 moa_engine.py stop            # removes it completely</a:t>
             </a:r>
           </a:p>
         </p:txBody>
@@ -15603,7 +15603,7 @@
                 </a:solidFill>
                 <a:latin typeface="Arial"/>
               </a:rPr>
-              <a:t>Send a single 92 KB file. Nothing to unzip, no folder to keep together.</a:t>
+              <a:t>Send one file, ~93 KB. Nothing to unzip, and it is both the app and the command line.</a:t>
             </a:r>
           </a:p>
           <a:p>
@@ -15625,8 +15625,8 @@
                 </a:solidFill>
                 <a:latin typeface="Arial"/>
               </a:rPr>
-              <a:t>CTS MOA Engine.command     Mac
-CTS MOA Engine.bat             Windows</a:t>
+              <a:t>SEND THIS/CTS MOA Engine.command     Mac
+SEND THIS/CTS MOA Engine.bat             Windows</a:t>
             </a:r>
           </a:p>
           <a:p>
@@ -15648,7 +15648,7 @@
                 </a:solidFill>
                 <a:latin typeface="Arial"/>
               </a:rPr>
-              <a:t>The whole engine is compressed inside and loaded from memory. On first run it creates a working folder beside itself for input and results.</a:t>
+              <a:t>Compressed inside and loaded from memory. First run creates a working folder beside it for input and results.</a:t>
             </a:r>
           </a:p>
           <a:p>

</xml_diff>

<commit_message>
Deck: state that it runs standalone, and why LinkedIn is not used
Two things a recipient asks that the deck did not answer.

"Runs on its own — no AI, no account, no API key, no server" is now the first
safety rail, because the whole point of the single-file build is that it works
on a machine with nothing set up.

The limitations slide now records why current-employer verification stays
manual: LinkedIn's terms prohibit automated access and it returns HTTP 405 to
non-browser requests, so it is not an option. Written down so it does not get
re-proposed later.

Co-Authored-By: Claude Opus 5 (1M context) <noreply@anthropic.com>
</commit_message>
<xml_diff>
--- a/How the MOA sourcing engine works.pptx
+++ b/How the MOA sourcing engine works.pptx
@@ -5284,7 +5284,7 @@
                 </a:solidFill>
                 <a:latin typeface="Arial"/>
               </a:rPr>
-              <a:t>— people move; the tool flags it but cannot confirm where they are now</a:t>
+              <a:t>— people move. The tool flags a likely move but cannot confirm a current employer. LinkedIn is not an option: its terms prohibit automated access and it refuses non-browser requests outright, so this stays a manual check</a:t>
             </a:r>
           </a:p>
           <a:p>
@@ -15309,7 +15309,7 @@
         <p:spPr>
           <a:xfrm>
             <a:off x="7607808" y="1298448"/>
-            <a:ext cx="4016959" cy="2331720"/>
+            <a:ext cx="4016959" cy="2651760"/>
           </a:xfrm>
           <a:prstGeom prst="rect">
             <a:avLst/>
@@ -15394,22 +15394,22 @@
               </a:spcAft>
             </a:pPr>
             <a:r>
-              <a:rPr sz="1050" b="1">
+              <a:rPr sz="950" b="1">
                 <a:solidFill>
                   <a:srgbClr val="1C222B"/>
                 </a:solidFill>
                 <a:latin typeface="Arial"/>
               </a:rPr>
-              <a:t>✓  Dry run by default — </a:t>
-            </a:r>
-            <a:r>
-              <a:rPr sz="1050">
+              <a:t>✓  Runs on its own — </a:t>
+            </a:r>
+            <a:r>
+              <a:rPr sz="950">
                 <a:solidFill>
                   <a:srgbClr val="535C69"/>
                 </a:solidFill>
                 <a:latin typeface="Arial"/>
               </a:rPr>
-              <a:t>nothing is written without --go</a:t>
+              <a:t>no AI, no Claude, no account, no API key, no server — Python 3 and a connection to the FDA and PubMed, nothing else</a:t>
             </a:r>
           </a:p>
           <a:p>
@@ -15422,22 +15422,22 @@
               </a:spcAft>
             </a:pPr>
             <a:r>
-              <a:rPr sz="1050" b="1">
+              <a:rPr sz="950" b="1">
                 <a:solidFill>
                   <a:srgbClr val="1C222B"/>
                 </a:solidFill>
                 <a:latin typeface="Arial"/>
               </a:rPr>
-              <a:t>✓  No email, ever — </a:t>
-            </a:r>
-            <a:r>
-              <a:rPr sz="1050">
+              <a:t>✓  Dry run by default — </a:t>
+            </a:r>
+            <a:r>
+              <a:rPr sz="950">
                 <a:solidFill>
                   <a:srgbClr val="535C69"/>
                 </a:solidFill>
                 <a:latin typeface="Arial"/>
               </a:rPr>
-              <a:t>invitations are drafted for you to send</a:t>
+              <a:t>nothing is written without --go</a:t>
             </a:r>
           </a:p>
           <a:p>
@@ -15450,22 +15450,22 @@
               </a:spcAft>
             </a:pPr>
             <a:r>
-              <a:rPr sz="1050" b="1">
+              <a:rPr sz="950" b="1">
                 <a:solidFill>
                   <a:srgbClr val="1C222B"/>
                 </a:solidFill>
                 <a:latin typeface="Arial"/>
               </a:rPr>
-              <a:t>✓  Your columns are yours — </a:t>
-            </a:r>
-            <a:r>
-              <a:rPr sz="1050">
+              <a:t>✓  No email, ever — </a:t>
+            </a:r>
+            <a:r>
+              <a:rPr sz="950">
                 <a:solidFill>
                   <a:srgbClr val="535C69"/>
                 </a:solidFill>
                 <a:latin typeface="Arial"/>
               </a:rPr>
-              <a:t>AE owner and Status are never overwritten</a:t>
+              <a:t>invitations are drafted for you to send</a:t>
             </a:r>
           </a:p>
           <a:p>
@@ -15478,16 +15478,44 @@
               </a:spcAft>
             </a:pPr>
             <a:r>
-              <a:rPr sz="1050" b="1">
+              <a:rPr sz="950" b="1">
                 <a:solidFill>
                   <a:srgbClr val="1C222B"/>
                 </a:solidFill>
                 <a:latin typeface="Arial"/>
               </a:rPr>
+              <a:t>✓  Your columns are yours — </a:t>
+            </a:r>
+            <a:r>
+              <a:rPr sz="950">
+                <a:solidFill>
+                  <a:srgbClr val="535C69"/>
+                </a:solidFill>
+                <a:latin typeface="Arial"/>
+              </a:rPr>
+              <a:t>AE owner and Status are never overwritten</a:t>
+            </a:r>
+          </a:p>
+          <a:p>
+            <a:pPr>
+              <a:lnSpc>
+                <a:spcPct val="108000"/>
+              </a:lnSpc>
+              <a:spcAft>
+                <a:spcPts val="700"/>
+              </a:spcAft>
+            </a:pPr>
+            <a:r>
+              <a:rPr sz="950" b="1">
+                <a:solidFill>
+                  <a:srgbClr val="1C222B"/>
+                </a:solidFill>
+                <a:latin typeface="Arial"/>
+              </a:rPr>
               <a:t>✓  No guessed contacts — </a:t>
             </a:r>
             <a:r>
-              <a:rPr sz="1050">
+              <a:rPr sz="950">
                 <a:solidFill>
                   <a:srgbClr val="535C69"/>
                 </a:solidFill>
@@ -15506,8 +15534,8 @@
         </p:nvSpPr>
         <p:spPr>
           <a:xfrm>
-            <a:off x="7607808" y="3767328"/>
-            <a:ext cx="4016959" cy="2286000"/>
+            <a:off x="7607808" y="4078224"/>
+            <a:ext cx="4016959" cy="1975104"/>
           </a:xfrm>
           <a:prstGeom prst="roundRect">
             <a:avLst>
@@ -15552,8 +15580,8 @@
         </p:nvSpPr>
         <p:spPr>
           <a:xfrm>
-            <a:off x="7790688" y="3913632"/>
-            <a:ext cx="3651199" cy="2011680"/>
+            <a:off x="7790688" y="4206240"/>
+            <a:ext cx="3651199" cy="1737360"/>
           </a:xfrm>
           <a:prstGeom prst="rect">
             <a:avLst/>
@@ -15603,7 +15631,7 @@
                 </a:solidFill>
                 <a:latin typeface="Arial"/>
               </a:rPr>
-              <a:t>Send one file, ~93 KB. Nothing to unzip, and it is both the app and the command line.</a:t>
+              <a:t>Send one file, ~93 KB. Both the app and the command line.</a:t>
             </a:r>
           </a:p>
           <a:p>
@@ -15648,7 +15676,7 @@
                 </a:solidFill>
                 <a:latin typeface="Arial"/>
               </a:rPr>
-              <a:t>Compressed inside and loaded from memory. First run creates a working folder beside it for input and results.</a:t>
+              <a:t>Loaded from memory; first run creates a working folder beside it.</a:t>
             </a:r>
           </a:p>
           <a:p>

</xml_diff>